<commit_message>
LP-IV: Montiel Olea-Pflueger effective F; TeX and slides show IV results
- an_lpiv_energy_ea.do: first-stage strength measured by the effective F of
  Montiel Olea and Pflueger (weakivtest, HAC-robust) against the critical
  value for a $lp_ivtau% maximum 2SLS bias, reported only in the log; lags of
  y, s and controls in both stages (made explicit in the header)
- master.do: lp_ivtau replaces the fixed weak-F threshold
- main_graphs.tex: IV results in the main text and appendices (labour market,
  robustness), OLS graphs in a comparison appendix (incl. electricity);
  comment placeholders for the IV results
- nota_drift.tex: IV methodology, instruments, effective F; IV figures
- make_slides_drift.js / slides_drift.pptx: IV graphs, takeaway placeholders,
  instrument details in the footnotes
- README, CLAUDE.md updated

Co-Authored-By: Claude Opus 5.5 <noreply@anthropic.com>
Claude-Session: https://claude.ai/code/session_01R4y3gP1fLvmmBfvtJmhgcd
</commit_message>
<xml_diff>
--- a/slides_drift.pptx
+++ b/slides_drift.pptx
@@ -108,7 +108,7 @@
   <p:extLst>
     <p:ext uri="{521415D9-36F7-43E2-AB2F-B90AF26B5E84}">
       <p14:sectionLst xmlns:p14="http://schemas.microsoft.com/office/powerpoint/2010/main">
-        <p14:section name="Results" id="{f743686a-90fc-086b-1122-5e0d9eb7f33e}">
+        <p14:section name="Results" id="{04aa9b15-d253-4dca-4cc5-c46a6a520354}">
           <p14:sldIdLst>
             <p14:sldId id="256"/>
             <p14:sldId id="257"/>
@@ -712,8 +712,8 @@
         </p:nvSpPr>
         <p:spPr>
           <a:xfrm>
-            <a:off x="457200" y="320040"/>
-            <a:ext cx="11274552" cy="731520"/>
+            <a:off x="457200" y="274320"/>
+            <a:ext cx="11274552" cy="640080"/>
           </a:xfrm>
           <a:prstGeom prst="rect">
             <a:avLst/>
@@ -1153,8 +1153,8 @@
         </p:nvSpPr>
         <p:spPr>
           <a:xfrm>
-            <a:off x="457200" y="320040"/>
-            <a:ext cx="11274552" cy="731520"/>
+            <a:off x="457200" y="274320"/>
+            <a:ext cx="11274552" cy="640080"/>
           </a:xfrm>
           <a:prstGeom prst="rect">
             <a:avLst/>
@@ -1178,7 +1178,7 @@
                 <a:ea typeface="Arial" pitchFamily="34" charset="-122"/>
                 <a:cs typeface="Arial" pitchFamily="34" charset="-120"/>
               </a:rPr>
-              <a:t>Euro area: wage response to oil and gas price shocks</a:t>
+              <a:t>Euro area: wage response to oil and gas supply shocks (IV)</a:t>
             </a:r>
             <a:endParaRPr lang="en-US" sz="2800" dirty="0"/>
           </a:p>
@@ -1192,7 +1192,60 @@
         </p:nvSpPr>
         <p:spPr>
           <a:xfrm>
-            <a:off x="457200" y="1188720"/>
+            <a:off x="457200" y="914400"/>
+            <a:ext cx="11274552" cy="365760"/>
+          </a:xfrm>
+          <a:prstGeom prst="rect">
+            <a:avLst/>
+          </a:prstGeom>
+          <a:noFill/>
+          <a:ln/>
+        </p:spPr>
+        <p:txBody>
+          <a:bodyPr wrap="square" lIns="0" tIns="0" rIns="0" bIns="0" rtlCol="0" anchor="ctr"/>
+          <a:lstStyle/>
+          <a:p>
+            <a:pPr indent="0" marL="0">
+              <a:buNone/>
+            </a:pPr>
+            <a:r>
+              <a:rPr lang="en-US" sz="1400" b="1" dirty="0">
+                <a:solidFill>
+                  <a:srgbClr val="1F2937"/>
+                </a:solidFill>
+                <a:latin typeface="Arial" pitchFamily="34" charset="0"/>
+                <a:ea typeface="Arial" pitchFamily="34" charset="-122"/>
+                <a:cs typeface="Arial" pitchFamily="34" charset="-120"/>
+              </a:rPr>
+              <a:t>Takeaway: </a:t>
+            </a:r>
+            <a:pPr indent="0" marL="0">
+              <a:buNone/>
+            </a:pPr>
+            <a:r>
+              <a:rPr lang="en-US" sz="1400" dirty="0">
+                <a:solidFill>
+                  <a:srgbClr val="C00000"/>
+                </a:solidFill>
+                <a:latin typeface="Arial" pitchFamily="34" charset="0"/>
+                <a:ea typeface="Arial" pitchFamily="34" charset="-122"/>
+                <a:cs typeface="Arial" pitchFamily="34" charset="-120"/>
+              </a:rPr>
+              <a:t>[TO BE COMPLETED: response of euro-area negotiated and hourly wages to oil and gas price increases driven by supply shocks]</a:t>
+            </a:r>
+            <a:endParaRPr lang="en-US" sz="1400" dirty="0"/>
+          </a:p>
+        </p:txBody>
+      </p:sp>
+      <p:sp>
+        <p:nvSpPr>
+          <p:cNvPr id="4" name="Text 2"/>
+          <p:cNvSpPr txBox="1"/>
+          <p:nvPr/>
+        </p:nvSpPr>
+        <p:spPr>
+          <a:xfrm>
+            <a:off x="457200" y="1371600"/>
             <a:ext cx="5486400" cy="365760"/>
           </a:xfrm>
           <a:prstGeom prst="rect">
@@ -1225,13 +1278,13 @@
       </p:sp>
       <p:sp>
         <p:nvSpPr>
-          <p:cNvPr id="4" name="Text 2"/>
+          <p:cNvPr id="5" name="Text 3"/>
           <p:cNvSpPr txBox="1"/>
           <p:nvPr/>
         </p:nvSpPr>
         <p:spPr>
           <a:xfrm>
-            <a:off x="6245352" y="1188720"/>
+            <a:off x="6245352" y="1371600"/>
             <a:ext cx="5486400" cy="365760"/>
           </a:xfrm>
           <a:prstGeom prst="rect">
@@ -1264,13 +1317,13 @@
       </p:sp>
       <p:sp>
         <p:nvSpPr>
-          <p:cNvPr id="5" name="placeholder lp_og_EA_contr.png"/>
+          <p:cNvPr id="6" name="placeholder lp_iv_og_EA_contr.png"/>
           <p:cNvSpPr txBox="1"/>
           <p:nvPr/>
         </p:nvSpPr>
         <p:spPr>
           <a:xfrm>
-            <a:off x="457200" y="1645920"/>
+            <a:off x="457200" y="1783080"/>
             <a:ext cx="5486400" cy="3986784"/>
           </a:xfrm>
           <a:prstGeom prst="rect">
@@ -1301,7 +1354,7 @@
                 <a:ea typeface="Arial" pitchFamily="34" charset="-122"/>
                 <a:cs typeface="Arial" pitchFamily="34" charset="-120"/>
               </a:rPr>
-              <a:t>Graph to be inserted: graphs/lp_og_EA_contr.png</a:t>
+              <a:t>Graph to be inserted: graphs/lp_iv_og_EA_contr.png</a:t>
             </a:r>
             <a:endParaRPr lang="en-US" sz="1400" dirty="0"/>
           </a:p>
@@ -1318,7 +1371,7 @@
                 <a:ea typeface="Arial" pitchFamily="34" charset="-122"/>
                 <a:cs typeface="Arial" pitchFamily="34" charset="-120"/>
               </a:rPr>
-              <a:t>(produced by an_lp_energy_ea.do)</a:t>
+              <a:t>(produced by the Stata run of master.do)</a:t>
             </a:r>
             <a:endParaRPr lang="en-US" sz="1400" dirty="0"/>
           </a:p>
@@ -1326,13 +1379,13 @@
       </p:sp>
       <p:sp>
         <p:nvSpPr>
-          <p:cNvPr id="6" name="placeholder lp_og_EA_wageH.png"/>
+          <p:cNvPr id="7" name="placeholder lp_iv_og_EA_wageH.png"/>
           <p:cNvSpPr txBox="1"/>
           <p:nvPr/>
         </p:nvSpPr>
         <p:spPr>
           <a:xfrm>
-            <a:off x="6245352" y="1645920"/>
+            <a:off x="6245352" y="1783080"/>
             <a:ext cx="5486400" cy="3986784"/>
           </a:xfrm>
           <a:prstGeom prst="rect">
@@ -1363,7 +1416,7 @@
                 <a:ea typeface="Arial" pitchFamily="34" charset="-122"/>
                 <a:cs typeface="Arial" pitchFamily="34" charset="-120"/>
               </a:rPr>
-              <a:t>Graph to be inserted: graphs/lp_og_EA_wageH.png</a:t>
+              <a:t>Graph to be inserted: graphs/lp_iv_og_EA_wageH.png</a:t>
             </a:r>
             <a:endParaRPr lang="en-US" sz="1400" dirty="0"/>
           </a:p>
@@ -1380,7 +1433,7 @@
                 <a:ea typeface="Arial" pitchFamily="34" charset="-122"/>
                 <a:cs typeface="Arial" pitchFamily="34" charset="-120"/>
               </a:rPr>
-              <a:t>(produced by an_lp_energy_ea.do)</a:t>
+              <a:t>(produced by the Stata run of master.do)</a:t>
             </a:r>
             <a:endParaRPr lang="en-US" sz="1400" dirty="0"/>
           </a:p>
@@ -1388,13 +1441,13 @@
       </p:sp>
       <p:sp>
         <p:nvSpPr>
-          <p:cNvPr id="7" name="Text 5"/>
+          <p:cNvPr id="8" name="Text 6"/>
           <p:cNvSpPr txBox="1"/>
           <p:nvPr/>
         </p:nvSpPr>
         <p:spPr>
           <a:xfrm>
-            <a:off x="457200" y="5852160"/>
+            <a:off x="457200" y="5897880"/>
             <a:ext cx="11274552" cy="685800"/>
           </a:xfrm>
           <a:prstGeom prst="rect">
@@ -1419,7 +1472,7 @@
                 <a:ea typeface="Arial" pitchFamily="34" charset="-122"/>
                 <a:cs typeface="Arial" pitchFamily="34" charset="-120"/>
               </a:rPr>
-              <a:t>Response (percentage points) of year-on-year wage growth to a 10 percentage point increase in the year-on-year growth of the oil and natural gas prices; 90% confidence bands. Local projections on euro-area time series. Sample (shock dates): negotiated wages, [sample period: available after running master.do]; hourly wages, [sample period: available after running master.do].</a:t>
+              <a:t>Response (percentage points) of year-on-year wage growth to a 10 percentage point increase in the year-on-year growth of the oil and natural gas prices; 90% confidence bands. 2SLS local projections: the oil price is instrumented with the Mori–Peersman oil supply news shocks, the gas price with the Alessandri–Gazzani gas supply shocks (three monthly shocks per quarter as instruments). Euro-area time series, Newey–West standard errors. Sample (shock dates): negotiated wages, [sample period: available after running master.do]; hourly wages, [sample period: available after running master.do].</a:t>
             </a:r>
             <a:endParaRPr lang="en-US" sz="1000" dirty="0"/>
           </a:p>
@@ -1508,8 +1561,8 @@
         </p:nvSpPr>
         <p:spPr>
           <a:xfrm>
-            <a:off x="457200" y="320040"/>
-            <a:ext cx="11274552" cy="731520"/>
+            <a:off x="457200" y="274320"/>
+            <a:ext cx="11274552" cy="640080"/>
           </a:xfrm>
           <a:prstGeom prst="rect">
             <a:avLst/>
@@ -1533,7 +1586,7 @@
                 <a:ea typeface="Arial" pitchFamily="34" charset="-122"/>
                 <a:cs typeface="Arial" pitchFamily="34" charset="-120"/>
               </a:rPr>
-              <a:t>Countries: wage response to oil and gas price shocks</a:t>
+              <a:t>Countries: wage response to oil and gas supply shocks (IV)</a:t>
             </a:r>
             <a:endParaRPr lang="en-US" sz="2800" dirty="0"/>
           </a:p>
@@ -1547,7 +1600,60 @@
         </p:nvSpPr>
         <p:spPr>
           <a:xfrm>
-            <a:off x="457200" y="1188720"/>
+            <a:off x="457200" y="914400"/>
+            <a:ext cx="11274552" cy="365760"/>
+          </a:xfrm>
+          <a:prstGeom prst="rect">
+            <a:avLst/>
+          </a:prstGeom>
+          <a:noFill/>
+          <a:ln/>
+        </p:spPr>
+        <p:txBody>
+          <a:bodyPr wrap="square" lIns="0" tIns="0" rIns="0" bIns="0" rtlCol="0" anchor="ctr"/>
+          <a:lstStyle/>
+          <a:p>
+            <a:pPr indent="0" marL="0">
+              <a:buNone/>
+            </a:pPr>
+            <a:r>
+              <a:rPr lang="en-US" sz="1400" b="1" dirty="0">
+                <a:solidFill>
+                  <a:srgbClr val="1F2937"/>
+                </a:solidFill>
+                <a:latin typeface="Arial" pitchFamily="34" charset="0"/>
+                <a:ea typeface="Arial" pitchFamily="34" charset="-122"/>
+                <a:cs typeface="Arial" pitchFamily="34" charset="-120"/>
+              </a:rPr>
+              <a:t>Takeaway: </a:t>
+            </a:r>
+            <a:pPr indent="0" marL="0">
+              <a:buNone/>
+            </a:pPr>
+            <a:r>
+              <a:rPr lang="en-US" sz="1400" dirty="0">
+                <a:solidFill>
+                  <a:srgbClr val="C00000"/>
+                </a:solidFill>
+                <a:latin typeface="Arial" pitchFamily="34" charset="0"/>
+                <a:ea typeface="Arial" pitchFamily="34" charset="-122"/>
+                <a:cs typeface="Arial" pitchFamily="34" charset="-120"/>
+              </a:rPr>
+              <a:t>[TO BE COMPLETED: cross-country differences in the IV responses and oil versus gas]</a:t>
+            </a:r>
+            <a:endParaRPr lang="en-US" sz="1400" dirty="0"/>
+          </a:p>
+        </p:txBody>
+      </p:sp>
+      <p:sp>
+        <p:nvSpPr>
+          <p:cNvPr id="4" name="Text 2"/>
+          <p:cNvSpPr txBox="1"/>
+          <p:nvPr/>
+        </p:nvSpPr>
+        <p:spPr>
+          <a:xfrm>
+            <a:off x="457200" y="1371600"/>
             <a:ext cx="5486400" cy="365760"/>
           </a:xfrm>
           <a:prstGeom prst="rect">
@@ -1580,13 +1686,13 @@
       </p:sp>
       <p:sp>
         <p:nvSpPr>
-          <p:cNvPr id="4" name="Text 2"/>
+          <p:cNvPr id="5" name="Text 3"/>
           <p:cNvSpPr txBox="1"/>
           <p:nvPr/>
         </p:nvSpPr>
         <p:spPr>
           <a:xfrm>
-            <a:off x="6245352" y="1188720"/>
+            <a:off x="6245352" y="1371600"/>
             <a:ext cx="5486400" cy="365760"/>
           </a:xfrm>
           <a:prstGeom prst="rect">
@@ -1619,14 +1725,14 @@
       </p:sp>
       <p:sp>
         <p:nvSpPr>
-          <p:cNvPr id="5" name="placeholder lp_og_ctry_contr_sq.png"/>
+          <p:cNvPr id="6" name="placeholder lp_iv_og_ctry_contr_sq.png"/>
           <p:cNvSpPr txBox="1"/>
           <p:nvPr/>
         </p:nvSpPr>
         <p:spPr>
           <a:xfrm>
-            <a:off x="1120140" y="1645920"/>
-            <a:ext cx="4160520" cy="4160520"/>
+            <a:off x="1188720" y="1783080"/>
+            <a:ext cx="4023360" cy="4023360"/>
           </a:xfrm>
           <a:prstGeom prst="rect">
             <a:avLst/>
@@ -1656,7 +1762,7 @@
                 <a:ea typeface="Arial" pitchFamily="34" charset="-122"/>
                 <a:cs typeface="Arial" pitchFamily="34" charset="-120"/>
               </a:rPr>
-              <a:t>Graph to be inserted: graphs/lp_og_ctry_contr_sq.png</a:t>
+              <a:t>Graph to be inserted: graphs/lp_iv_og_ctry_contr_sq.png</a:t>
             </a:r>
             <a:endParaRPr lang="en-US" sz="1400" dirty="0"/>
           </a:p>
@@ -1673,7 +1779,7 @@
                 <a:ea typeface="Arial" pitchFamily="34" charset="-122"/>
                 <a:cs typeface="Arial" pitchFamily="34" charset="-120"/>
               </a:rPr>
-              <a:t>(produced by an_lp_energy_ea.do)</a:t>
+              <a:t>(produced by the Stata run of master.do)</a:t>
             </a:r>
             <a:endParaRPr lang="en-US" sz="1400" dirty="0"/>
           </a:p>
@@ -1681,14 +1787,14 @@
       </p:sp>
       <p:sp>
         <p:nvSpPr>
-          <p:cNvPr id="6" name="placeholder lp_og_ctry_wageH_sq.png"/>
+          <p:cNvPr id="7" name="placeholder lp_iv_og_ctry_wageH_sq.png"/>
           <p:cNvSpPr txBox="1"/>
           <p:nvPr/>
         </p:nvSpPr>
         <p:spPr>
           <a:xfrm>
-            <a:off x="6908292" y="1645920"/>
-            <a:ext cx="4160520" cy="4160520"/>
+            <a:off x="6976872" y="1783080"/>
+            <a:ext cx="4023360" cy="4023360"/>
           </a:xfrm>
           <a:prstGeom prst="rect">
             <a:avLst/>
@@ -1718,7 +1824,7 @@
                 <a:ea typeface="Arial" pitchFamily="34" charset="-122"/>
                 <a:cs typeface="Arial" pitchFamily="34" charset="-120"/>
               </a:rPr>
-              <a:t>Graph to be inserted: graphs/lp_og_ctry_wageH_sq.png</a:t>
+              <a:t>Graph to be inserted: graphs/lp_iv_og_ctry_wageH_sq.png</a:t>
             </a:r>
             <a:endParaRPr lang="en-US" sz="1400" dirty="0"/>
           </a:p>
@@ -1735,7 +1841,7 @@
                 <a:ea typeface="Arial" pitchFamily="34" charset="-122"/>
                 <a:cs typeface="Arial" pitchFamily="34" charset="-120"/>
               </a:rPr>
-              <a:t>(produced by an_lp_energy_ea.do)</a:t>
+              <a:t>(produced by the Stata run of master.do)</a:t>
             </a:r>
             <a:endParaRPr lang="en-US" sz="1400" dirty="0"/>
           </a:p>
@@ -1743,13 +1849,13 @@
       </p:sp>
       <p:sp>
         <p:nvSpPr>
-          <p:cNvPr id="7" name="Text 5"/>
+          <p:cNvPr id="8" name="Text 6"/>
           <p:cNvSpPr txBox="1"/>
           <p:nvPr/>
         </p:nvSpPr>
         <p:spPr>
           <a:xfrm>
-            <a:off x="457200" y="5943600"/>
+            <a:off x="457200" y="5897880"/>
             <a:ext cx="11274552" cy="685800"/>
           </a:xfrm>
           <a:prstGeom prst="rect">
@@ -1774,7 +1880,7 @@
                 <a:ea typeface="Arial" pitchFamily="34" charset="-122"/>
                 <a:cs typeface="Arial" pitchFamily="34" charset="-120"/>
               </a:rPr>
-              <a:t>Response (percentage points) of year-on-year wage growth to a 10 percentage point increase in the year-on-year growth of the oil and natural gas prices; 90% confidence bands. Local projections on time series for the euro area and each country; same vertical scale within each graph; the sample period (shock dates) of each panel is shown under its name.</a:t>
+              <a:t>Response (percentage points) of year-on-year wage growth to a 10 percentage point increase in the year-on-year growth of the oil and natural gas prices; 90% confidence bands. 2SLS local projections: the oil price is instrumented with the Mori–Peersman oil supply news shocks, the gas price with the Alessandri–Gazzani gas supply shocks (three monthly shocks per quarter as instruments). Time series for the euro area and each country, Newey–West standard errors; same vertical scale within each graph; the sample period (shock dates) of each panel is shown under its name.</a:t>
             </a:r>
             <a:endParaRPr lang="en-US" sz="1000" dirty="0"/>
           </a:p>

</xml_diff>

<commit_message>
LP-IV: q-o-q price shocks, quarterly instrument baseline, reduced form, smooth LP
- Energy prices enter as quarter-on-quarter log changes (shock = +10% price);
  outcomes stay year-on-year (INWR only exists as a yoy rate)
- Baseline instrument = quarterly average of the monthly shocks; the three
  monthly shocks (U-MIDAS) become the robustness variant umid
- Lags cut from 4 to 2; COVID dummy plus its lags among the controls
- Reduced-form LPs on the instruments (1-s.d. shock), oil and gas, in an
  appendix (lp_rf_og_*)
- Smooth LP-IV (Barnichon-Brownlees) as robustness, Mata lp_slp(),
  cross-validated penalty
- README, CLAUDE.md, main_graphs.tex, note and slides updated

Co-Authored-By: Claude Opus 5.5 <noreply@anthropic.com>
Claude-Session: https://claude.ai/code/session_01R4y3gP1fLvmmBfvtJmhgcd
</commit_message>
<xml_diff>
--- a/slides_drift.pptx
+++ b/slides_drift.pptx
@@ -108,7 +108,7 @@
   <p:extLst>
     <p:ext uri="{521415D9-36F7-43E2-AB2F-B90AF26B5E84}">
       <p14:sectionLst xmlns:p14="http://schemas.microsoft.com/office/powerpoint/2010/main">
-        <p14:section name="Results" id="{04aa9b15-d253-4dca-4cc5-c46a6a520354}">
+        <p14:section name="Results" id="{5790a8ea-ef7c-a654-25d7-3cd5ec7b76f9}">
           <p14:sldIdLst>
             <p14:sldId id="256"/>
             <p14:sldId id="257"/>
@@ -1315,12 +1315,20 @@
           </a:p>
         </p:txBody>
       </p:sp>
-      <p:sp>
-        <p:nvSpPr>
-          <p:cNvPr id="6" name="placeholder lp_iv_og_EA_contr.png"/>
-          <p:cNvSpPr txBox="1"/>
+      <p:pic>
+        <p:nvPicPr>
+          <p:cNvPr id="6" name="lp_iv_og_EA_contr.png" descr="lp_iv_og_EA_contr.png">    </p:cNvPr>
+          <p:cNvPicPr>
+            <a:picLocks noChangeAspect="1"/>
+          </p:cNvPicPr>
           <p:nvPr/>
-        </p:nvSpPr>
+        </p:nvPicPr>
+        <p:blipFill>
+          <a:blip r:embed="rId1"/>
+          <a:stretch>
+            <a:fillRect/>
+          </a:stretch>
+        </p:blipFill>
         <p:spPr>
           <a:xfrm>
             <a:off x="457200" y="1783080"/>
@@ -1329,60 +1337,22 @@
           <a:prstGeom prst="rect">
             <a:avLst/>
           </a:prstGeom>
-          <a:solidFill>
-            <a:srgbClr val="F1F3F5"/>
-          </a:solidFill>
-          <a:ln w="9525">
-            <a:solidFill>
-              <a:srgbClr val="D0D4DA"/>
-            </a:solidFill>
-          </a:ln>
-        </p:spPr>
-        <p:txBody>
-          <a:bodyPr wrap="square" rtlCol="0" anchor="ctr"/>
-          <a:lstStyle/>
-          <a:p>
-            <a:pPr algn="ctr" indent="0" marL="0">
-              <a:buNone/>
-            </a:pPr>
-            <a:r>
-              <a:rPr lang="en-US" sz="1400" dirty="0">
-                <a:solidFill>
-                  <a:srgbClr val="5B6472"/>
-                </a:solidFill>
-                <a:latin typeface="Arial" pitchFamily="34" charset="0"/>
-                <a:ea typeface="Arial" pitchFamily="34" charset="-122"/>
-                <a:cs typeface="Arial" pitchFamily="34" charset="-120"/>
-              </a:rPr>
-              <a:t>Graph to be inserted: graphs/lp_iv_og_EA_contr.png</a:t>
-            </a:r>
-            <a:endParaRPr lang="en-US" sz="1400" dirty="0"/>
-          </a:p>
-          <a:p>
-            <a:pPr algn="ctr" indent="0" marL="0">
-              <a:buNone/>
-            </a:pPr>
-            <a:r>
-              <a:rPr lang="en-US" sz="1400" dirty="0">
-                <a:solidFill>
-                  <a:srgbClr val="5B6472"/>
-                </a:solidFill>
-                <a:latin typeface="Arial" pitchFamily="34" charset="0"/>
-                <a:ea typeface="Arial" pitchFamily="34" charset="-122"/>
-                <a:cs typeface="Arial" pitchFamily="34" charset="-120"/>
-              </a:rPr>
-              <a:t>(produced by the Stata run of master.do)</a:t>
-            </a:r>
-            <a:endParaRPr lang="en-US" sz="1400" dirty="0"/>
-          </a:p>
-        </p:txBody>
-      </p:sp>
-      <p:sp>
-        <p:nvSpPr>
-          <p:cNvPr id="7" name="placeholder lp_iv_og_EA_wageH.png"/>
-          <p:cNvSpPr txBox="1"/>
+        </p:spPr>
+      </p:pic>
+      <p:pic>
+        <p:nvPicPr>
+          <p:cNvPr id="7" name="lp_iv_og_EA_wageH.png" descr="lp_iv_og_EA_wageH.png">    </p:cNvPr>
+          <p:cNvPicPr>
+            <a:picLocks noChangeAspect="1"/>
+          </p:cNvPicPr>
           <p:nvPr/>
-        </p:nvSpPr>
+        </p:nvPicPr>
+        <p:blipFill>
+          <a:blip r:embed="rId2"/>
+          <a:stretch>
+            <a:fillRect/>
+          </a:stretch>
+        </p:blipFill>
         <p:spPr>
           <a:xfrm>
             <a:off x="6245352" y="1783080"/>
@@ -1391,57 +1361,11 @@
           <a:prstGeom prst="rect">
             <a:avLst/>
           </a:prstGeom>
-          <a:solidFill>
-            <a:srgbClr val="F1F3F5"/>
-          </a:solidFill>
-          <a:ln w="9525">
-            <a:solidFill>
-              <a:srgbClr val="D0D4DA"/>
-            </a:solidFill>
-          </a:ln>
-        </p:spPr>
-        <p:txBody>
-          <a:bodyPr wrap="square" rtlCol="0" anchor="ctr"/>
-          <a:lstStyle/>
-          <a:p>
-            <a:pPr algn="ctr" indent="0" marL="0">
-              <a:buNone/>
-            </a:pPr>
-            <a:r>
-              <a:rPr lang="en-US" sz="1400" dirty="0">
-                <a:solidFill>
-                  <a:srgbClr val="5B6472"/>
-                </a:solidFill>
-                <a:latin typeface="Arial" pitchFamily="34" charset="0"/>
-                <a:ea typeface="Arial" pitchFamily="34" charset="-122"/>
-                <a:cs typeface="Arial" pitchFamily="34" charset="-120"/>
-              </a:rPr>
-              <a:t>Graph to be inserted: graphs/lp_iv_og_EA_wageH.png</a:t>
-            </a:r>
-            <a:endParaRPr lang="en-US" sz="1400" dirty="0"/>
-          </a:p>
-          <a:p>
-            <a:pPr algn="ctr" indent="0" marL="0">
-              <a:buNone/>
-            </a:pPr>
-            <a:r>
-              <a:rPr lang="en-US" sz="1400" dirty="0">
-                <a:solidFill>
-                  <a:srgbClr val="5B6472"/>
-                </a:solidFill>
-                <a:latin typeface="Arial" pitchFamily="34" charset="0"/>
-                <a:ea typeface="Arial" pitchFamily="34" charset="-122"/>
-                <a:cs typeface="Arial" pitchFamily="34" charset="-120"/>
-              </a:rPr>
-              <a:t>(produced by the Stata run of master.do)</a:t>
-            </a:r>
-            <a:endParaRPr lang="en-US" sz="1400" dirty="0"/>
-          </a:p>
-        </p:txBody>
-      </p:sp>
-      <p:sp>
-        <p:nvSpPr>
-          <p:cNvPr id="8" name="Text 6"/>
+        </p:spPr>
+      </p:pic>
+      <p:sp>
+        <p:nvSpPr>
+          <p:cNvPr id="8" name="Text 4"/>
           <p:cNvSpPr txBox="1"/>
           <p:nvPr/>
         </p:nvSpPr>
@@ -1472,7 +1396,7 @@
                 <a:ea typeface="Arial" pitchFamily="34" charset="-122"/>
                 <a:cs typeface="Arial" pitchFamily="34" charset="-120"/>
               </a:rPr>
-              <a:t>Response (percentage points) of year-on-year wage growth to a 10 percentage point increase in the year-on-year growth of the oil and natural gas prices; 90% confidence bands. 2SLS local projections: the oil price is instrumented with the Mori–Peersman oil supply news shocks, the gas price with the Alessandri–Gazzani gas supply shocks (three monthly shocks per quarter as instruments). Euro-area time series, Newey–West standard errors. Sample (shock dates): negotiated wages, [sample period: available after running master.do]; hourly wages, [sample period: available after running master.do].</a:t>
+              <a:t>Response (percentage points) of year-on-year wage growth to a 10% increase in the oil and natural gas prices; 90% confidence bands. 2SLS local projections: the oil price is instrumented with the Mori–Peersman oil supply news shocks, the gas price with the Alessandri–Gazzani gas supply shocks (quarterly average of the monthly shocks). Euro-area time series, Newey–West standard errors. Sample (shock dates): negotiated wages, oil 2001q1–2025q4; gas 2008q1–2025q4; hourly wages, oil 2001q1–2025q4; gas 2008q1–2025q4.</a:t>
             </a:r>
             <a:endParaRPr lang="en-US" sz="1000" dirty="0"/>
           </a:p>
@@ -1723,12 +1647,20 @@
           </a:p>
         </p:txBody>
       </p:sp>
-      <p:sp>
-        <p:nvSpPr>
-          <p:cNvPr id="6" name="placeholder lp_iv_og_ctry_contr_sq.png"/>
-          <p:cNvSpPr txBox="1"/>
+      <p:pic>
+        <p:nvPicPr>
+          <p:cNvPr id="6" name="lp_iv_og_ctry_contr_sq.png" descr="lp_iv_og_ctry_contr_sq.png">    </p:cNvPr>
+          <p:cNvPicPr>
+            <a:picLocks noChangeAspect="1"/>
+          </p:cNvPicPr>
           <p:nvPr/>
-        </p:nvSpPr>
+        </p:nvPicPr>
+        <p:blipFill>
+          <a:blip r:embed="rId1"/>
+          <a:stretch>
+            <a:fillRect/>
+          </a:stretch>
+        </p:blipFill>
         <p:spPr>
           <a:xfrm>
             <a:off x="1188720" y="1783080"/>
@@ -1737,60 +1669,22 @@
           <a:prstGeom prst="rect">
             <a:avLst/>
           </a:prstGeom>
-          <a:solidFill>
-            <a:srgbClr val="F1F3F5"/>
-          </a:solidFill>
-          <a:ln w="9525">
-            <a:solidFill>
-              <a:srgbClr val="D0D4DA"/>
-            </a:solidFill>
-          </a:ln>
-        </p:spPr>
-        <p:txBody>
-          <a:bodyPr wrap="square" rtlCol="0" anchor="ctr"/>
-          <a:lstStyle/>
-          <a:p>
-            <a:pPr algn="ctr" indent="0" marL="0">
-              <a:buNone/>
-            </a:pPr>
-            <a:r>
-              <a:rPr lang="en-US" sz="1400" dirty="0">
-                <a:solidFill>
-                  <a:srgbClr val="5B6472"/>
-                </a:solidFill>
-                <a:latin typeface="Arial" pitchFamily="34" charset="0"/>
-                <a:ea typeface="Arial" pitchFamily="34" charset="-122"/>
-                <a:cs typeface="Arial" pitchFamily="34" charset="-120"/>
-              </a:rPr>
-              <a:t>Graph to be inserted: graphs/lp_iv_og_ctry_contr_sq.png</a:t>
-            </a:r>
-            <a:endParaRPr lang="en-US" sz="1400" dirty="0"/>
-          </a:p>
-          <a:p>
-            <a:pPr algn="ctr" indent="0" marL="0">
-              <a:buNone/>
-            </a:pPr>
-            <a:r>
-              <a:rPr lang="en-US" sz="1400" dirty="0">
-                <a:solidFill>
-                  <a:srgbClr val="5B6472"/>
-                </a:solidFill>
-                <a:latin typeface="Arial" pitchFamily="34" charset="0"/>
-                <a:ea typeface="Arial" pitchFamily="34" charset="-122"/>
-                <a:cs typeface="Arial" pitchFamily="34" charset="-120"/>
-              </a:rPr>
-              <a:t>(produced by the Stata run of master.do)</a:t>
-            </a:r>
-            <a:endParaRPr lang="en-US" sz="1400" dirty="0"/>
-          </a:p>
-        </p:txBody>
-      </p:sp>
-      <p:sp>
-        <p:nvSpPr>
-          <p:cNvPr id="7" name="placeholder lp_iv_og_ctry_wageH_sq.png"/>
-          <p:cNvSpPr txBox="1"/>
+        </p:spPr>
+      </p:pic>
+      <p:pic>
+        <p:nvPicPr>
+          <p:cNvPr id="7" name="lp_iv_og_ctry_wageH_sq.png" descr="lp_iv_og_ctry_wageH_sq.png">    </p:cNvPr>
+          <p:cNvPicPr>
+            <a:picLocks noChangeAspect="1"/>
+          </p:cNvPicPr>
           <p:nvPr/>
-        </p:nvSpPr>
+        </p:nvPicPr>
+        <p:blipFill>
+          <a:blip r:embed="rId2"/>
+          <a:stretch>
+            <a:fillRect/>
+          </a:stretch>
+        </p:blipFill>
         <p:spPr>
           <a:xfrm>
             <a:off x="6976872" y="1783080"/>
@@ -1799,57 +1693,11 @@
           <a:prstGeom prst="rect">
             <a:avLst/>
           </a:prstGeom>
-          <a:solidFill>
-            <a:srgbClr val="F1F3F5"/>
-          </a:solidFill>
-          <a:ln w="9525">
-            <a:solidFill>
-              <a:srgbClr val="D0D4DA"/>
-            </a:solidFill>
-          </a:ln>
-        </p:spPr>
-        <p:txBody>
-          <a:bodyPr wrap="square" rtlCol="0" anchor="ctr"/>
-          <a:lstStyle/>
-          <a:p>
-            <a:pPr algn="ctr" indent="0" marL="0">
-              <a:buNone/>
-            </a:pPr>
-            <a:r>
-              <a:rPr lang="en-US" sz="1400" dirty="0">
-                <a:solidFill>
-                  <a:srgbClr val="5B6472"/>
-                </a:solidFill>
-                <a:latin typeface="Arial" pitchFamily="34" charset="0"/>
-                <a:ea typeface="Arial" pitchFamily="34" charset="-122"/>
-                <a:cs typeface="Arial" pitchFamily="34" charset="-120"/>
-              </a:rPr>
-              <a:t>Graph to be inserted: graphs/lp_iv_og_ctry_wageH_sq.png</a:t>
-            </a:r>
-            <a:endParaRPr lang="en-US" sz="1400" dirty="0"/>
-          </a:p>
-          <a:p>
-            <a:pPr algn="ctr" indent="0" marL="0">
-              <a:buNone/>
-            </a:pPr>
-            <a:r>
-              <a:rPr lang="en-US" sz="1400" dirty="0">
-                <a:solidFill>
-                  <a:srgbClr val="5B6472"/>
-                </a:solidFill>
-                <a:latin typeface="Arial" pitchFamily="34" charset="0"/>
-                <a:ea typeface="Arial" pitchFamily="34" charset="-122"/>
-                <a:cs typeface="Arial" pitchFamily="34" charset="-120"/>
-              </a:rPr>
-              <a:t>(produced by the Stata run of master.do)</a:t>
-            </a:r>
-            <a:endParaRPr lang="en-US" sz="1400" dirty="0"/>
-          </a:p>
-        </p:txBody>
-      </p:sp>
-      <p:sp>
-        <p:nvSpPr>
-          <p:cNvPr id="8" name="Text 6"/>
+        </p:spPr>
+      </p:pic>
+      <p:sp>
+        <p:nvSpPr>
+          <p:cNvPr id="8" name="Text 4"/>
           <p:cNvSpPr txBox="1"/>
           <p:nvPr/>
         </p:nvSpPr>
@@ -1880,7 +1728,7 @@
                 <a:ea typeface="Arial" pitchFamily="34" charset="-122"/>
                 <a:cs typeface="Arial" pitchFamily="34" charset="-120"/>
               </a:rPr>
-              <a:t>Response (percentage points) of year-on-year wage growth to a 10 percentage point increase in the year-on-year growth of the oil and natural gas prices; 90% confidence bands. 2SLS local projections: the oil price is instrumented with the Mori–Peersman oil supply news shocks, the gas price with the Alessandri–Gazzani gas supply shocks (three monthly shocks per quarter as instruments). Time series for the euro area and each country, Newey–West standard errors; same vertical scale within each graph; the sample period (shock dates) of each panel is shown under its name.</a:t>
+              <a:t>Response (percentage points) of year-on-year wage growth to a 10% increase in the oil and natural gas prices; 90% confidence bands. 2SLS local projections: the oil price is instrumented with the Mori–Peersman oil supply news shocks, the gas price with the Alessandri–Gazzani gas supply shocks (quarterly average of the monthly shocks). Time series for the euro area and each country, Newey–West standard errors; same vertical scale within each graph; the sample period (shock dates) of each panel is shown under its name.</a:t>
             </a:r>
             <a:endParaRPr lang="en-US" sz="1000" dirty="0"/>
           </a:p>

</xml_diff>

<commit_message>
LP-IV: smooth LP as baseline with undersmoothed bands; unsmoothed to robustness
- Variant base = smooth LP-IV (Barnichon-Brownlees); the previous
  horizon-by-horizon 2SLS becomes variant unsm ("Unsmoothed" in graphs)
- Confidence bands by undersmoothing: standard errors and band centre (bc)
  from the penalty divided by $lp_slp_us (default 10); line = cross-validated
  estimate (b)
- Robustness graphs: smooth baseline with band, unsmoothed, monthly
  instruments, pre-Covid
- README, CLAUDE.md, main_graphs.tex, note and slides updated

Co-Authored-By: Claude Opus 5.5 <noreply@anthropic.com>
Claude-Session: https://claude.ai/code/session_01R4y3gP1fLvmmBfvtJmhgcd
</commit_message>
<xml_diff>
--- a/slides_drift.pptx
+++ b/slides_drift.pptx
@@ -108,7 +108,7 @@
   <p:extLst>
     <p:ext uri="{521415D9-36F7-43E2-AB2F-B90AF26B5E84}">
       <p14:sectionLst xmlns:p14="http://schemas.microsoft.com/office/powerpoint/2010/main">
-        <p14:section name="Results" id="{5790a8ea-ef7c-a654-25d7-3cd5ec7b76f9}">
+        <p14:section name="Results" id="{03a528bd-adb5-9eca-d5a7-0a743c271e2d}">
           <p14:sldIdLst>
             <p14:sldId id="256"/>
             <p14:sldId id="257"/>
@@ -1396,7 +1396,7 @@
                 <a:ea typeface="Arial" pitchFamily="34" charset="-122"/>
                 <a:cs typeface="Arial" pitchFamily="34" charset="-120"/>
               </a:rPr>
-              <a:t>Response (percentage points) of year-on-year wage growth to a 10% increase in the oil and natural gas prices; 90% confidence bands. 2SLS local projections: the oil price is instrumented with the Mori–Peersman oil supply news shocks, the gas price with the Alessandri–Gazzani gas supply shocks (quarterly average of the monthly shocks). Euro-area time series, Newey–West standard errors. Sample (shock dates): negotiated wages, oil 2001q1–2025q4; gas 2008q1–2025q4; hourly wages, oil 2001q1–2025q4; gas 2008q1–2025q4.</a:t>
+              <a:t>Response (percentage points) of year-on-year wage growth to a 10% increase in the oil and natural gas prices; 90% confidence bands. Smooth 2SLS local projections (Barnichon–Brownlees; bands by undersmoothing): the oil price is instrumented with the Mori–Peersman oil supply news shocks, the gas price with the Alessandri–Gazzani gas supply shocks (quarterly average of the monthly shocks). Euro-area time series, Newey–West standard errors. Sample (shock dates): negotiated wages, oil 2000q3–2025q4; gas 2006q4–2025q4; hourly wages, oil 2000q3–2025q4; gas 2006q4–2025q4.</a:t>
             </a:r>
             <a:endParaRPr lang="en-US" sz="1000" dirty="0"/>
           </a:p>
@@ -1728,7 +1728,7 @@
                 <a:ea typeface="Arial" pitchFamily="34" charset="-122"/>
                 <a:cs typeface="Arial" pitchFamily="34" charset="-120"/>
               </a:rPr>
-              <a:t>Response (percentage points) of year-on-year wage growth to a 10% increase in the oil and natural gas prices; 90% confidence bands. 2SLS local projections: the oil price is instrumented with the Mori–Peersman oil supply news shocks, the gas price with the Alessandri–Gazzani gas supply shocks (quarterly average of the monthly shocks). Time series for the euro area and each country, Newey–West standard errors; same vertical scale within each graph; the sample period (shock dates) of each panel is shown under its name.</a:t>
+              <a:t>Response (percentage points) of year-on-year wage growth to a 10% increase in the oil and natural gas prices; 90% confidence bands. Smooth 2SLS local projections (Barnichon–Brownlees; bands by undersmoothing): the oil price is instrumented with the Mori–Peersman oil supply news shocks, the gas price with the Alessandri–Gazzani gas supply shocks (quarterly average of the monthly shocks). Time series for the euro area and each country, Newey–West standard errors; same vertical scale within each graph; the sample period (shock dates) of each panel is shown under its name.</a:t>
             </a:r>
             <a:endParaRPr lang="en-US" sz="1000" dirty="0"/>
           </a:p>

</xml_diff>

<commit_message>
Y axes of multi-panel graphs: common only if band widths are similar
- lp_ypanels: common y axis if the widths of the 90% bands (max hi90 - min
  lo90 per panel) differ across panels by at most $lp_ytol (1.6 pp);
  otherwise each panel gets its own tight axis with the label step of the
  common axis; decision printed in the log
- lp_yaxis: optional label step; a panel that does not reach one step away
  from 0 is extended to one step
- Applied to the appendix and oil+gas country graphs (IV and OLS files)
- master.do: new parameter lp_ytol; README, CLAUDE.md, main_graphs.tex and
  slide footnote updated

Co-Authored-By: Claude Opus 5.5 <noreply@anthropic.com>
Claude-Session: https://claude.ai/code/session_01R4y3gP1fLvmmBfvtJmhgcd
</commit_message>
<xml_diff>
--- a/slides_drift.pptx
+++ b/slides_drift.pptx
@@ -108,7 +108,7 @@
   <p:extLst>
     <p:ext uri="{521415D9-36F7-43E2-AB2F-B90AF26B5E84}">
       <p14:sectionLst xmlns:p14="http://schemas.microsoft.com/office/powerpoint/2010/main">
-        <p14:section name="Results" id="{03a528bd-adb5-9eca-d5a7-0a743c271e2d}">
+        <p14:section name="Results" id="{1b81744c-a98d-a96b-9dbe-733165c1320e}">
           <p14:sldIdLst>
             <p14:sldId id="256"/>
             <p14:sldId id="257"/>
@@ -1728,7 +1728,7 @@
                 <a:ea typeface="Arial" pitchFamily="34" charset="-122"/>
                 <a:cs typeface="Arial" pitchFamily="34" charset="-120"/>
               </a:rPr>
-              <a:t>Response (percentage points) of year-on-year wage growth to a 10% increase in the oil and natural gas prices; 90% confidence bands. Smooth 2SLS local projections (Barnichon–Brownlees; bands by undersmoothing): the oil price is instrumented with the Mori–Peersman oil supply news shocks, the gas price with the Alessandri–Gazzani gas supply shocks (quarterly average of the monthly shocks). Time series for the euro area and each country, Newey–West standard errors; same vertical scale within each graph; the sample period (shock dates) of each panel is shown under its name.</a:t>
+              <a:t>Response (percentage points) of year-on-year wage growth to a 10% increase in the oil and natural gas prices; 90% confidence bands. Smooth 2SLS local projections (Barnichon–Brownlees; bands by undersmoothing): the oil price is instrumented with the Mori–Peersman oil supply news shocks, the gas price with the Alessandri–Gazzani gas supply shocks (quarterly average of the monthly shocks). Time series for the euro area and each country, Newey–West standard errors; same vertical scale in all panels unless the widths of the confidence bands differ by more than 1.6 pp (then each panel has its own scale, with the same spacing between labels); the sample period (shock dates) of each panel is shown under its name.</a:t>
             </a:r>
             <a:endParaRPr lang="en-US" sz="1000" dirty="0"/>
           </a:p>

</xml_diff>